<commit_message>
added figures for model comparison
</commit_message>
<xml_diff>
--- a/Credit Risk Prediction System.pptx
+++ b/Credit Risk Prediction System.pptx
@@ -151,7 +151,7 @@
   <pc:docChgLst>
     <pc:chgData name="Thembelihle Nkosi" userId="34acb82be647289d" providerId="LiveId" clId="{A75475CB-E90B-49A7-8916-1196816BF4F1}"/>
     <pc:docChg chg="undo custSel addSld delSld modSld">
-      <pc:chgData name="Thembelihle Nkosi" userId="34acb82be647289d" providerId="LiveId" clId="{A75475CB-E90B-49A7-8916-1196816BF4F1}" dt="2026-09-02T08:46:53.098" v="4655" actId="20577"/>
+      <pc:chgData name="Thembelihle Nkosi" userId="34acb82be647289d" providerId="LiveId" clId="{A75475CB-E90B-49A7-8916-1196816BF4F1}" dt="2026-09-02T08:54:58.314" v="4662" actId="14100"/>
       <pc:docMkLst>
         <pc:docMk/>
       </pc:docMkLst>
@@ -613,8 +613,8 @@
           <pc:sldMk cId="2169082369" sldId="265"/>
         </pc:sldMkLst>
       </pc:sldChg>
-      <pc:sldChg chg="addSp modSp new mod modClrScheme chgLayout">
-        <pc:chgData name="Thembelihle Nkosi" userId="34acb82be647289d" providerId="LiveId" clId="{A75475CB-E90B-49A7-8916-1196816BF4F1}" dt="2026-09-02T08:26:57.205" v="4291" actId="14100"/>
+      <pc:sldChg chg="addSp delSp modSp new mod modClrScheme chgLayout">
+        <pc:chgData name="Thembelihle Nkosi" userId="34acb82be647289d" providerId="LiveId" clId="{A75475CB-E90B-49A7-8916-1196816BF4F1}" dt="2026-09-02T08:54:58.314" v="4662" actId="14100"/>
         <pc:sldMkLst>
           <pc:docMk/>
           <pc:sldMk cId="4224083050" sldId="265"/>
@@ -667,12 +667,28 @@
             <ac:spMk id="8" creationId="{3202D219-EFBD-0B93-72B9-EB96D28B3591}"/>
           </ac:spMkLst>
         </pc:spChg>
-        <pc:picChg chg="add mod">
-          <ac:chgData name="Thembelihle Nkosi" userId="34acb82be647289d" providerId="LiveId" clId="{A75475CB-E90B-49A7-8916-1196816BF4F1}" dt="2026-09-02T08:26:57.205" v="4291" actId="14100"/>
+        <pc:picChg chg="add del mod">
+          <ac:chgData name="Thembelihle Nkosi" userId="34acb82be647289d" providerId="LiveId" clId="{A75475CB-E90B-49A7-8916-1196816BF4F1}" dt="2026-09-02T08:54:29.433" v="4656" actId="21"/>
           <ac:picMkLst>
             <pc:docMk/>
             <pc:sldMk cId="4224083050" sldId="265"/>
             <ac:picMk id="10" creationId="{6C017206-1816-2CDA-9AE8-0959A0BF2D66}"/>
+          </ac:picMkLst>
+        </pc:picChg>
+        <pc:picChg chg="add del">
+          <ac:chgData name="Thembelihle Nkosi" userId="34acb82be647289d" providerId="LiveId" clId="{A75475CB-E90B-49A7-8916-1196816BF4F1}" dt="2026-09-02T08:54:35.976" v="4658" actId="21"/>
+          <ac:picMkLst>
+            <pc:docMk/>
+            <pc:sldMk cId="4224083050" sldId="265"/>
+            <ac:picMk id="12" creationId="{36AC9BE9-4539-6549-8BC2-B6731EB2566C}"/>
+          </ac:picMkLst>
+        </pc:picChg>
+        <pc:picChg chg="add mod">
+          <ac:chgData name="Thembelihle Nkosi" userId="34acb82be647289d" providerId="LiveId" clId="{A75475CB-E90B-49A7-8916-1196816BF4F1}" dt="2026-09-02T08:54:58.314" v="4662" actId="14100"/>
+          <ac:picMkLst>
+            <pc:docMk/>
+            <pc:sldMk cId="4224083050" sldId="265"/>
+            <ac:picMk id="14" creationId="{7ACB0A52-45EA-4374-3541-223AAE63F5F4}"/>
           </ac:picMkLst>
         </pc:picChg>
       </pc:sldChg>
@@ -23721,10 +23737,10 @@
       </p:sp>
       <p:pic>
         <p:nvPicPr>
-          <p:cNvPr id="10" name="Picture 9">
-            <a:extLst>
-              <a:ext uri="{FF2B5EF4-FFF2-40B4-BE49-F238E27FC236}">
-                <a16:creationId xmlns:a16="http://schemas.microsoft.com/office/drawing/2014/main" id="{6C017206-1816-2CDA-9AE8-0959A0BF2D66}"/>
+          <p:cNvPr id="14" name="Picture 13">
+            <a:extLst>
+              <a:ext uri="{FF2B5EF4-FFF2-40B4-BE49-F238E27FC236}">
+                <a16:creationId xmlns:a16="http://schemas.microsoft.com/office/drawing/2014/main" id="{7ACB0A52-45EA-4374-3541-223AAE63F5F4}"/>
               </a:ext>
             </a:extLst>
           </p:cNvPr>
@@ -23747,8 +23763,8 @@
         </p:blipFill>
         <p:spPr>
           <a:xfrm>
-            <a:off x="4668416" y="1658034"/>
-            <a:ext cx="6826898" cy="4571692"/>
+            <a:off x="4525346" y="1483721"/>
+            <a:ext cx="7333862" cy="4571692"/>
           </a:xfrm>
           <a:prstGeom prst="rect">
             <a:avLst/>

</xml_diff>

<commit_message>
Created a bar graph for model performance
</commit_message>
<xml_diff>
--- a/Credit Risk Prediction System.pptx
+++ b/Credit Risk Prediction System.pptx
@@ -5,10 +5,10 @@
     <p:sldMasterId id="2147483979" r:id="rId1"/>
   </p:sldMasterIdLst>
   <p:notesMasterIdLst>
-    <p:notesMasterId r:id="rId9"/>
+    <p:notesMasterId r:id="rId11"/>
   </p:notesMasterIdLst>
   <p:handoutMasterIdLst>
-    <p:handoutMasterId r:id="rId10"/>
+    <p:handoutMasterId r:id="rId12"/>
   </p:handoutMasterIdLst>
   <p:sldIdLst>
     <p:sldId id="260" r:id="rId2"/>
@@ -18,6 +18,8 @@
     <p:sldId id="264" r:id="rId6"/>
     <p:sldId id="265" r:id="rId7"/>
     <p:sldId id="266" r:id="rId8"/>
+    <p:sldId id="267" r:id="rId9"/>
+    <p:sldId id="268" r:id="rId10"/>
   </p:sldIdLst>
   <p:sldSz cx="12192000" cy="6858000"/>
   <p:notesSz cx="6858000" cy="9144000"/>
@@ -141,7 +143,7 @@
 <file path=ppt/revisionInfo.xml><?xml version="1.0" encoding="utf-8"?>
 <p1510:revInfo xmlns:a="http://schemas.openxmlformats.org/drawingml/2006/main" xmlns:r="http://schemas.openxmlformats.org/officeDocument/2006/relationships" xmlns:p1510="http://schemas.microsoft.com/office/powerpoint/2015/10/main">
   <p1510:revLst>
-    <p1510:client id="{5F03DC37-C6E7-4D03-9B6A-5B1F4D882761}" v="50" dt="2026-09-02T08:36:14.898"/>
+    <p1510:client id="{5F03DC37-C6E7-4D03-9B6A-5B1F4D882761}" v="55" dt="2026-09-02T12:50:12.272"/>
   </p1510:revLst>
 </p1510:revInfo>
 </file>
@@ -151,7 +153,7 @@
   <pc:docChgLst>
     <pc:chgData name="Thembelihle Nkosi" userId="34acb82be647289d" providerId="LiveId" clId="{A75475CB-E90B-49A7-8916-1196816BF4F1}"/>
     <pc:docChg chg="undo custSel addSld delSld modSld">
-      <pc:chgData name="Thembelihle Nkosi" userId="34acb82be647289d" providerId="LiveId" clId="{A75475CB-E90B-49A7-8916-1196816BF4F1}" dt="2026-09-02T08:54:58.314" v="4662" actId="14100"/>
+      <pc:chgData name="Thembelihle Nkosi" userId="34acb82be647289d" providerId="LiveId" clId="{A75475CB-E90B-49A7-8916-1196816BF4F1}" dt="2026-09-02T12:50:16.342" v="5261"/>
       <pc:docMkLst>
         <pc:docMk/>
       </pc:docMkLst>
@@ -614,7 +616,7 @@
         </pc:sldMkLst>
       </pc:sldChg>
       <pc:sldChg chg="addSp delSp modSp new mod modClrScheme chgLayout">
-        <pc:chgData name="Thembelihle Nkosi" userId="34acb82be647289d" providerId="LiveId" clId="{A75475CB-E90B-49A7-8916-1196816BF4F1}" dt="2026-09-02T08:54:58.314" v="4662" actId="14100"/>
+        <pc:chgData name="Thembelihle Nkosi" userId="34acb82be647289d" providerId="LiveId" clId="{A75475CB-E90B-49A7-8916-1196816BF4F1}" dt="2026-09-02T12:50:16.342" v="5261"/>
         <pc:sldMkLst>
           <pc:docMk/>
           <pc:sldMk cId="4224083050" sldId="265"/>
@@ -649,6 +651,14 @@
             <pc:docMk/>
             <pc:sldMk cId="4224083050" sldId="265"/>
             <ac:spMk id="5" creationId="{101B37D2-ABBA-15BF-263E-02D2CA6E3131}"/>
+          </ac:spMkLst>
+        </pc:spChg>
+        <pc:spChg chg="add del mod">
+          <ac:chgData name="Thembelihle Nkosi" userId="34acb82be647289d" providerId="LiveId" clId="{A75475CB-E90B-49A7-8916-1196816BF4F1}" dt="2026-09-02T12:50:16.342" v="5261"/>
+          <ac:spMkLst>
+            <pc:docMk/>
+            <pc:sldMk cId="4224083050" sldId="265"/>
+            <ac:spMk id="6" creationId="{11132FD8-86E5-183A-E5A5-09C8A2BE04C7}"/>
           </ac:spMkLst>
         </pc:spChg>
         <pc:spChg chg="add mod">
@@ -693,7 +703,7 @@
         </pc:picChg>
       </pc:sldChg>
       <pc:sldChg chg="addSp modSp new mod chgLayout">
-        <pc:chgData name="Thembelihle Nkosi" userId="34acb82be647289d" providerId="LiveId" clId="{A75475CB-E90B-49A7-8916-1196816BF4F1}" dt="2026-09-02T08:46:53.098" v="4655" actId="20577"/>
+        <pc:chgData name="Thembelihle Nkosi" userId="34acb82be647289d" providerId="LiveId" clId="{A75475CB-E90B-49A7-8916-1196816BF4F1}" dt="2026-09-02T09:15:00.665" v="4863" actId="1076"/>
         <pc:sldMkLst>
           <pc:docMk/>
           <pc:sldMk cId="4169104927" sldId="266"/>
@@ -722,6 +732,14 @@
             <ac:spMk id="4" creationId="{7C1039FA-C227-0728-B80A-A04A4B6CE04E}"/>
           </ac:spMkLst>
         </pc:spChg>
+        <pc:spChg chg="add mod">
+          <ac:chgData name="Thembelihle Nkosi" userId="34acb82be647289d" providerId="LiveId" clId="{A75475CB-E90B-49A7-8916-1196816BF4F1}" dt="2026-09-02T09:15:00.665" v="4863" actId="1076"/>
+          <ac:spMkLst>
+            <pc:docMk/>
+            <pc:sldMk cId="4169104927" sldId="266"/>
+            <ac:spMk id="8" creationId="{1CC28A71-0F06-8525-75AF-BF1E0CCC5550}"/>
+          </ac:spMkLst>
+        </pc:spChg>
         <pc:graphicFrameChg chg="add mod modGraphic">
           <ac:chgData name="Thembelihle Nkosi" userId="34acb82be647289d" providerId="LiveId" clId="{A75475CB-E90B-49A7-8916-1196816BF4F1}" dt="2026-09-02T08:46:53.098" v="4655" actId="20577"/>
           <ac:graphicFrameMkLst>
@@ -730,6 +748,14 @@
             <ac:graphicFrameMk id="5" creationId="{CCFB4286-0FB1-4E05-CAE8-526E19E62BD2}"/>
           </ac:graphicFrameMkLst>
         </pc:graphicFrameChg>
+        <pc:picChg chg="add mod">
+          <ac:chgData name="Thembelihle Nkosi" userId="34acb82be647289d" providerId="LiveId" clId="{A75475CB-E90B-49A7-8916-1196816BF4F1}" dt="2026-09-02T09:11:39.242" v="4668" actId="14100"/>
+          <ac:picMkLst>
+            <pc:docMk/>
+            <pc:sldMk cId="4169104927" sldId="266"/>
+            <ac:picMk id="7" creationId="{0A471F18-B616-4DFE-F6D2-6D7BFFD583DA}"/>
+          </ac:picMkLst>
+        </pc:picChg>
       </pc:sldChg>
       <pc:sldChg chg="new del">
         <pc:chgData name="Thembelihle Nkosi" userId="34acb82be647289d" providerId="LiveId" clId="{A75475CB-E90B-49A7-8916-1196816BF4F1}" dt="2026-09-02T08:29:25.749" v="4350" actId="2696"/>
@@ -737,6 +763,76 @@
           <pc:docMk/>
           <pc:sldMk cId="925457027" sldId="267"/>
         </pc:sldMkLst>
+      </pc:sldChg>
+      <pc:sldChg chg="addSp delSp modSp new mod">
+        <pc:chgData name="Thembelihle Nkosi" userId="34acb82be647289d" providerId="LiveId" clId="{A75475CB-E90B-49A7-8916-1196816BF4F1}" dt="2026-09-02T09:24:17.107" v="5228" actId="20577"/>
+        <pc:sldMkLst>
+          <pc:docMk/>
+          <pc:sldMk cId="2713236424" sldId="267"/>
+        </pc:sldMkLst>
+        <pc:spChg chg="add mod">
+          <ac:chgData name="Thembelihle Nkosi" userId="34acb82be647289d" providerId="LiveId" clId="{A75475CB-E90B-49A7-8916-1196816BF4F1}" dt="2026-09-02T09:17:10.509" v="4900" actId="1076"/>
+          <ac:spMkLst>
+            <pc:docMk/>
+            <pc:sldMk cId="2713236424" sldId="267"/>
+            <ac:spMk id="3" creationId="{3F0264F1-B19A-80A7-AAA9-D33FCAFE4996}"/>
+          </ac:spMkLst>
+        </pc:spChg>
+        <pc:spChg chg="add mod">
+          <ac:chgData name="Thembelihle Nkosi" userId="34acb82be647289d" providerId="LiveId" clId="{A75475CB-E90B-49A7-8916-1196816BF4F1}" dt="2026-09-02T09:18:17.008" v="4971" actId="1076"/>
+          <ac:spMkLst>
+            <pc:docMk/>
+            <pc:sldMk cId="2713236424" sldId="267"/>
+            <ac:spMk id="4" creationId="{C5C0F7E0-A1A8-3041-FEDB-470662BEF789}"/>
+          </ac:spMkLst>
+        </pc:spChg>
+        <pc:spChg chg="add mod">
+          <ac:chgData name="Thembelihle Nkosi" userId="34acb82be647289d" providerId="LiveId" clId="{A75475CB-E90B-49A7-8916-1196816BF4F1}" dt="2026-09-02T09:24:17.107" v="5228" actId="20577"/>
+          <ac:spMkLst>
+            <pc:docMk/>
+            <pc:sldMk cId="2713236424" sldId="267"/>
+            <ac:spMk id="12" creationId="{C4CDB01D-D9F1-2BB5-1F85-04A8D58029B2}"/>
+          </ac:spMkLst>
+        </pc:spChg>
+        <pc:graphicFrameChg chg="add mod modGraphic">
+          <ac:chgData name="Thembelihle Nkosi" userId="34acb82be647289d" providerId="LiveId" clId="{A75475CB-E90B-49A7-8916-1196816BF4F1}" dt="2026-09-02T09:19:33.559" v="5027" actId="20577"/>
+          <ac:graphicFrameMkLst>
+            <pc:docMk/>
+            <pc:sldMk cId="2713236424" sldId="267"/>
+            <ac:graphicFrameMk id="6" creationId="{D69D521A-2BF0-B65F-6A49-CE5AFAA45695}"/>
+          </ac:graphicFrameMkLst>
+        </pc:graphicFrameChg>
+        <pc:picChg chg="add del mod">
+          <ac:chgData name="Thembelihle Nkosi" userId="34acb82be647289d" providerId="LiveId" clId="{A75475CB-E90B-49A7-8916-1196816BF4F1}" dt="2026-09-02T09:21:08.953" v="5035" actId="22"/>
+          <ac:picMkLst>
+            <pc:docMk/>
+            <pc:sldMk cId="2713236424" sldId="267"/>
+            <ac:picMk id="8" creationId="{26969078-9E08-2F4D-EDDA-14A2E192FB1C}"/>
+          </ac:picMkLst>
+        </pc:picChg>
+        <pc:picChg chg="add mod">
+          <ac:chgData name="Thembelihle Nkosi" userId="34acb82be647289d" providerId="LiveId" clId="{A75475CB-E90B-49A7-8916-1196816BF4F1}" dt="2026-09-02T09:21:46.975" v="5040" actId="14100"/>
+          <ac:picMkLst>
+            <pc:docMk/>
+            <pc:sldMk cId="2713236424" sldId="267"/>
+            <ac:picMk id="10" creationId="{DDB6FD70-7166-B5A2-F84E-BE650511D505}"/>
+          </ac:picMkLst>
+        </pc:picChg>
+      </pc:sldChg>
+      <pc:sldChg chg="addSp modSp new mod">
+        <pc:chgData name="Thembelihle Nkosi" userId="34acb82be647289d" providerId="LiveId" clId="{A75475CB-E90B-49A7-8916-1196816BF4F1}" dt="2026-09-02T09:25:18.018" v="5258" actId="20577"/>
+        <pc:sldMkLst>
+          <pc:docMk/>
+          <pc:sldMk cId="4292511079" sldId="268"/>
+        </pc:sldMkLst>
+        <pc:spChg chg="add mod">
+          <ac:chgData name="Thembelihle Nkosi" userId="34acb82be647289d" providerId="LiveId" clId="{A75475CB-E90B-49A7-8916-1196816BF4F1}" dt="2026-09-02T09:25:18.018" v="5258" actId="20577"/>
+          <ac:spMkLst>
+            <pc:docMk/>
+            <pc:sldMk cId="4292511079" sldId="268"/>
+            <ac:spMk id="3" creationId="{C22A7DEA-FEE9-B9CB-5AF6-E2858E6D632E}"/>
+          </ac:spMkLst>
+        </pc:spChg>
       </pc:sldChg>
     </pc:docChg>
   </pc:docChgLst>
@@ -24636,10 +24732,1214 @@
           </a:graphicData>
         </a:graphic>
       </p:graphicFrame>
+      <p:pic>
+        <p:nvPicPr>
+          <p:cNvPr id="7" name="Picture 6">
+            <a:extLst>
+              <a:ext uri="{FF2B5EF4-FFF2-40B4-BE49-F238E27FC236}">
+                <a16:creationId xmlns:a16="http://schemas.microsoft.com/office/drawing/2014/main" id="{0A471F18-B616-4DFE-F6D2-6D7BFFD583DA}"/>
+              </a:ext>
+            </a:extLst>
+          </p:cNvPr>
+          <p:cNvPicPr>
+            <a:picLocks noChangeAspect="1"/>
+          </p:cNvPicPr>
+          <p:nvPr/>
+        </p:nvPicPr>
+        <p:blipFill>
+          <a:blip r:embed="rId2"/>
+          <a:stretch>
+            <a:fillRect/>
+          </a:stretch>
+        </p:blipFill>
+        <p:spPr>
+          <a:xfrm>
+            <a:off x="457199" y="3429000"/>
+            <a:ext cx="6232850" cy="3223727"/>
+          </a:xfrm>
+          <a:prstGeom prst="rect">
+            <a:avLst/>
+          </a:prstGeom>
+        </p:spPr>
+      </p:pic>
+      <p:sp>
+        <p:nvSpPr>
+          <p:cNvPr id="8" name="TextBox 7">
+            <a:extLst>
+              <a:ext uri="{FF2B5EF4-FFF2-40B4-BE49-F238E27FC236}">
+                <a16:creationId xmlns:a16="http://schemas.microsoft.com/office/drawing/2014/main" id="{1CC28A71-0F06-8525-75AF-BF1E0CCC5550}"/>
+              </a:ext>
+            </a:extLst>
+          </p:cNvPr>
+          <p:cNvSpPr txBox="1"/>
+          <p:nvPr/>
+        </p:nvSpPr>
+        <p:spPr>
+          <a:xfrm>
+            <a:off x="6921759" y="4376056"/>
+            <a:ext cx="3666931" cy="890115"/>
+          </a:xfrm>
+          <a:prstGeom prst="rect">
+            <a:avLst/>
+          </a:prstGeom>
+          <a:noFill/>
+        </p:spPr>
+        <p:txBody>
+          <a:bodyPr wrap="square" rtlCol="0">
+            <a:spAutoFit/>
+          </a:bodyPr>
+          <a:lstStyle/>
+          <a:p>
+            <a:pPr>
+              <a:lnSpc>
+                <a:spcPct val="150000"/>
+              </a:lnSpc>
+            </a:pPr>
+            <a:r>
+              <a:rPr lang="en-ZA" sz="1200" dirty="0">
+                <a:solidFill>
+                  <a:schemeClr val="tx2"/>
+                </a:solidFill>
+                <a:latin typeface="Times New Roman" panose="02020603050405020304" pitchFamily="18" charset="0"/>
+                <a:cs typeface="Times New Roman" panose="02020603050405020304" pitchFamily="18" charset="0"/>
+              </a:rPr>
+              <a:t>Decision tree leads on </a:t>
+            </a:r>
+            <a:r>
+              <a:rPr lang="en-ZA" sz="1200" b="1" dirty="0">
+                <a:solidFill>
+                  <a:schemeClr val="tx2"/>
+                </a:solidFill>
+                <a:latin typeface="Times New Roman" panose="02020603050405020304" pitchFamily="18" charset="0"/>
+                <a:cs typeface="Times New Roman" panose="02020603050405020304" pitchFamily="18" charset="0"/>
+              </a:rPr>
+              <a:t>Recall </a:t>
+            </a:r>
+            <a:r>
+              <a:rPr lang="en-ZA" sz="1200" dirty="0">
+                <a:solidFill>
+                  <a:schemeClr val="tx2"/>
+                </a:solidFill>
+                <a:latin typeface="Times New Roman" panose="02020603050405020304" pitchFamily="18" charset="0"/>
+                <a:cs typeface="Times New Roman" panose="02020603050405020304" pitchFamily="18" charset="0"/>
+              </a:rPr>
+              <a:t>and </a:t>
+            </a:r>
+            <a:r>
+              <a:rPr lang="en-ZA" sz="1200" b="1" dirty="0">
+                <a:solidFill>
+                  <a:schemeClr val="tx2"/>
+                </a:solidFill>
+                <a:latin typeface="Times New Roman" panose="02020603050405020304" pitchFamily="18" charset="0"/>
+                <a:cs typeface="Times New Roman" panose="02020603050405020304" pitchFamily="18" charset="0"/>
+              </a:rPr>
+              <a:t>F1-score </a:t>
+            </a:r>
+            <a:r>
+              <a:rPr lang="en-ZA" sz="1200" dirty="0">
+                <a:solidFill>
+                  <a:schemeClr val="tx2"/>
+                </a:solidFill>
+                <a:latin typeface="Times New Roman" panose="02020603050405020304" pitchFamily="18" charset="0"/>
+                <a:cs typeface="Times New Roman" panose="02020603050405020304" pitchFamily="18" charset="0"/>
+              </a:rPr>
+              <a:t>and this is important since missing a actual high-risk applicant (false negative) is costlier error for a lender.</a:t>
+            </a:r>
+          </a:p>
+        </p:txBody>
+      </p:sp>
     </p:spTree>
     <p:extLst>
       <p:ext uri="{BB962C8B-B14F-4D97-AF65-F5344CB8AC3E}">
         <p14:creationId xmlns:p14="http://schemas.microsoft.com/office/powerpoint/2010/main" val="4169104927"/>
+      </p:ext>
+    </p:extLst>
+  </p:cSld>
+  <p:clrMapOvr>
+    <a:masterClrMapping/>
+  </p:clrMapOvr>
+</p:sld>
+</file>
+
+<file path=ppt/slides/slide8.xml><?xml version="1.0" encoding="utf-8"?>
+<p:sld xmlns:a="http://schemas.openxmlformats.org/drawingml/2006/main" xmlns:r="http://schemas.openxmlformats.org/officeDocument/2006/relationships" xmlns:p="http://schemas.openxmlformats.org/presentationml/2006/main">
+  <p:cSld>
+    <p:spTree>
+      <p:nvGrpSpPr>
+        <p:cNvPr id="1" name=""/>
+        <p:cNvGrpSpPr/>
+        <p:nvPr/>
+      </p:nvGrpSpPr>
+      <p:grpSpPr>
+        <a:xfrm>
+          <a:off x="0" y="0"/>
+          <a:ext cx="0" cy="0"/>
+          <a:chOff x="0" y="0"/>
+          <a:chExt cx="0" cy="0"/>
+        </a:xfrm>
+      </p:grpSpPr>
+      <p:sp>
+        <p:nvSpPr>
+          <p:cNvPr id="2" name="Slide Number Placeholder 1">
+            <a:extLst>
+              <a:ext uri="{FF2B5EF4-FFF2-40B4-BE49-F238E27FC236}">
+                <a16:creationId xmlns:a16="http://schemas.microsoft.com/office/drawing/2014/main" id="{BE0B1EA4-825A-69C9-C93D-8B44711E18F3}"/>
+              </a:ext>
+            </a:extLst>
+          </p:cNvPr>
+          <p:cNvSpPr>
+            <a:spLocks noGrp="1"/>
+          </p:cNvSpPr>
+          <p:nvPr>
+            <p:ph type="sldNum" sz="quarter" idx="12"/>
+          </p:nvPr>
+        </p:nvSpPr>
+        <p:spPr/>
+        <p:txBody>
+          <a:bodyPr/>
+          <a:lstStyle/>
+          <a:p>
+            <a:fld id="{AEAA3239-9EA4-4A65-A281-97F994456D9F}" type="slidenum">
+              <a:rPr lang="en-US" smtClean="0"/>
+              <a:t>8</a:t>
+            </a:fld>
+            <a:endParaRPr lang="en-US"/>
+          </a:p>
+        </p:txBody>
+      </p:sp>
+      <p:sp>
+        <p:nvSpPr>
+          <p:cNvPr id="3" name="TextBox 2">
+            <a:extLst>
+              <a:ext uri="{FF2B5EF4-FFF2-40B4-BE49-F238E27FC236}">
+                <a16:creationId xmlns:a16="http://schemas.microsoft.com/office/drawing/2014/main" id="{3F0264F1-B19A-80A7-AAA9-D33FCAFE4996}"/>
+              </a:ext>
+            </a:extLst>
+          </p:cNvPr>
+          <p:cNvSpPr txBox="1"/>
+          <p:nvPr/>
+        </p:nvSpPr>
+        <p:spPr>
+          <a:xfrm>
+            <a:off x="681135" y="317241"/>
+            <a:ext cx="5025094" cy="661207"/>
+          </a:xfrm>
+          <a:prstGeom prst="rect">
+            <a:avLst/>
+          </a:prstGeom>
+          <a:noFill/>
+        </p:spPr>
+        <p:txBody>
+          <a:bodyPr wrap="none" rtlCol="0">
+            <a:spAutoFit/>
+          </a:bodyPr>
+          <a:lstStyle/>
+          <a:p>
+            <a:pPr>
+              <a:lnSpc>
+                <a:spcPct val="150000"/>
+              </a:lnSpc>
+            </a:pPr>
+            <a:r>
+              <a:rPr lang="en-ZA" sz="2800" b="1" dirty="0">
+                <a:solidFill>
+                  <a:schemeClr val="tx2"/>
+                </a:solidFill>
+                <a:latin typeface="Times New Roman" panose="02020603050405020304" pitchFamily="18" charset="0"/>
+                <a:cs typeface="Times New Roman" panose="02020603050405020304" pitchFamily="18" charset="0"/>
+              </a:rPr>
+              <a:t>Model comparison – After PCA</a:t>
+            </a:r>
+          </a:p>
+        </p:txBody>
+      </p:sp>
+      <p:sp>
+        <p:nvSpPr>
+          <p:cNvPr id="4" name="TextBox 3">
+            <a:extLst>
+              <a:ext uri="{FF2B5EF4-FFF2-40B4-BE49-F238E27FC236}">
+                <a16:creationId xmlns:a16="http://schemas.microsoft.com/office/drawing/2014/main" id="{C5C0F7E0-A1A8-3041-FEDB-470662BEF789}"/>
+              </a:ext>
+            </a:extLst>
+          </p:cNvPr>
+          <p:cNvSpPr txBox="1"/>
+          <p:nvPr/>
+        </p:nvSpPr>
+        <p:spPr>
+          <a:xfrm>
+            <a:off x="681135" y="1073021"/>
+            <a:ext cx="3948068" cy="336118"/>
+          </a:xfrm>
+          <a:prstGeom prst="rect">
+            <a:avLst/>
+          </a:prstGeom>
+          <a:noFill/>
+        </p:spPr>
+        <p:txBody>
+          <a:bodyPr wrap="none" rtlCol="0">
+            <a:spAutoFit/>
+          </a:bodyPr>
+          <a:lstStyle/>
+          <a:p>
+            <a:pPr>
+              <a:lnSpc>
+                <a:spcPct val="150000"/>
+              </a:lnSpc>
+            </a:pPr>
+            <a:r>
+              <a:rPr lang="en-ZA" sz="1200" dirty="0">
+                <a:latin typeface="Times New Roman" panose="02020603050405020304" pitchFamily="18" charset="0"/>
+                <a:cs typeface="Times New Roman" panose="02020603050405020304" pitchFamily="18" charset="0"/>
+              </a:rPr>
+              <a:t>Same three classifiers retrained on the PCA transformed data.</a:t>
+            </a:r>
+          </a:p>
+        </p:txBody>
+      </p:sp>
+      <p:graphicFrame>
+        <p:nvGraphicFramePr>
+          <p:cNvPr id="6" name="Table 5">
+            <a:extLst>
+              <a:ext uri="{FF2B5EF4-FFF2-40B4-BE49-F238E27FC236}">
+                <a16:creationId xmlns:a16="http://schemas.microsoft.com/office/drawing/2014/main" id="{D69D521A-2BF0-B65F-6A49-CE5AFAA45695}"/>
+              </a:ext>
+            </a:extLst>
+          </p:cNvPr>
+          <p:cNvGraphicFramePr>
+            <a:graphicFrameLocks noGrp="1"/>
+          </p:cNvGraphicFramePr>
+          <p:nvPr>
+            <p:extLst>
+              <p:ext uri="{D42A27DB-BD31-4B8C-83A1-F6EECF244321}">
+                <p14:modId xmlns:p14="http://schemas.microsoft.com/office/powerpoint/2010/main" val="2239864099"/>
+              </p:ext>
+            </p:extLst>
+          </p:nvPr>
+        </p:nvGraphicFramePr>
+        <p:xfrm>
+          <a:off x="681135" y="1689152"/>
+          <a:ext cx="6969965" cy="1483360"/>
+        </p:xfrm>
+        <a:graphic>
+          <a:graphicData uri="http://schemas.openxmlformats.org/drawingml/2006/table">
+            <a:tbl>
+              <a:tblPr firstRow="1" bandRow="1">
+                <a:tableStyleId>{8799B23B-EC83-4686-B30A-512413B5E67A}</a:tableStyleId>
+              </a:tblPr>
+              <a:tblGrid>
+                <a:gridCol w="1393993">
+                  <a:extLst>
+                    <a:ext uri="{9D8B030D-6E8A-4147-A177-3AD203B41FA5}">
+                      <a16:colId xmlns:a16="http://schemas.microsoft.com/office/drawing/2014/main" val="1116900852"/>
+                    </a:ext>
+                  </a:extLst>
+                </a:gridCol>
+                <a:gridCol w="1393993">
+                  <a:extLst>
+                    <a:ext uri="{9D8B030D-6E8A-4147-A177-3AD203B41FA5}">
+                      <a16:colId xmlns:a16="http://schemas.microsoft.com/office/drawing/2014/main" val="839705105"/>
+                    </a:ext>
+                  </a:extLst>
+                </a:gridCol>
+                <a:gridCol w="1393993">
+                  <a:extLst>
+                    <a:ext uri="{9D8B030D-6E8A-4147-A177-3AD203B41FA5}">
+                      <a16:colId xmlns:a16="http://schemas.microsoft.com/office/drawing/2014/main" val="2972379473"/>
+                    </a:ext>
+                  </a:extLst>
+                </a:gridCol>
+                <a:gridCol w="1393993">
+                  <a:extLst>
+                    <a:ext uri="{9D8B030D-6E8A-4147-A177-3AD203B41FA5}">
+                      <a16:colId xmlns:a16="http://schemas.microsoft.com/office/drawing/2014/main" val="3919136990"/>
+                    </a:ext>
+                  </a:extLst>
+                </a:gridCol>
+                <a:gridCol w="1393993">
+                  <a:extLst>
+                    <a:ext uri="{9D8B030D-6E8A-4147-A177-3AD203B41FA5}">
+                      <a16:colId xmlns:a16="http://schemas.microsoft.com/office/drawing/2014/main" val="2536520263"/>
+                    </a:ext>
+                  </a:extLst>
+                </a:gridCol>
+              </a:tblGrid>
+              <a:tr h="370840">
+                <a:tc>
+                  <a:txBody>
+                    <a:bodyPr/>
+                    <a:lstStyle/>
+                    <a:p>
+                      <a:pPr>
+                        <a:lnSpc>
+                          <a:spcPct val="150000"/>
+                        </a:lnSpc>
+                      </a:pPr>
+                      <a:r>
+                        <a:rPr lang="en-ZA" sz="1200" b="1" dirty="0">
+                          <a:solidFill>
+                            <a:schemeClr val="tx2"/>
+                          </a:solidFill>
+                          <a:latin typeface="Times New Roman" panose="02020603050405020304" pitchFamily="18" charset="0"/>
+                          <a:cs typeface="Times New Roman" panose="02020603050405020304" pitchFamily="18" charset="0"/>
+                        </a:rPr>
+                        <a:t>Model</a:t>
+                      </a:r>
+                    </a:p>
+                  </a:txBody>
+                  <a:tcPr>
+                    <a:solidFill>
+                      <a:schemeClr val="accent3">
+                        <a:lumMod val="40000"/>
+                        <a:lumOff val="60000"/>
+                      </a:schemeClr>
+                    </a:solidFill>
+                  </a:tcPr>
+                </a:tc>
+                <a:tc>
+                  <a:txBody>
+                    <a:bodyPr/>
+                    <a:lstStyle/>
+                    <a:p>
+                      <a:pPr>
+                        <a:lnSpc>
+                          <a:spcPct val="150000"/>
+                        </a:lnSpc>
+                      </a:pPr>
+                      <a:r>
+                        <a:rPr lang="en-ZA" sz="1200" dirty="0">
+                          <a:solidFill>
+                            <a:schemeClr val="tx2"/>
+                          </a:solidFill>
+                          <a:latin typeface="Times New Roman" panose="02020603050405020304" pitchFamily="18" charset="0"/>
+                          <a:cs typeface="Times New Roman" panose="02020603050405020304" pitchFamily="18" charset="0"/>
+                        </a:rPr>
+                        <a:t>Accuracy</a:t>
+                      </a:r>
+                    </a:p>
+                  </a:txBody>
+                  <a:tcPr>
+                    <a:solidFill>
+                      <a:schemeClr val="accent3">
+                        <a:lumMod val="40000"/>
+                        <a:lumOff val="60000"/>
+                      </a:schemeClr>
+                    </a:solidFill>
+                  </a:tcPr>
+                </a:tc>
+                <a:tc>
+                  <a:txBody>
+                    <a:bodyPr/>
+                    <a:lstStyle/>
+                    <a:p>
+                      <a:pPr>
+                        <a:lnSpc>
+                          <a:spcPct val="150000"/>
+                        </a:lnSpc>
+                      </a:pPr>
+                      <a:r>
+                        <a:rPr lang="en-ZA" sz="1200" dirty="0">
+                          <a:solidFill>
+                            <a:schemeClr val="tx2"/>
+                          </a:solidFill>
+                          <a:latin typeface="Times New Roman" panose="02020603050405020304" pitchFamily="18" charset="0"/>
+                          <a:cs typeface="Times New Roman" panose="02020603050405020304" pitchFamily="18" charset="0"/>
+                        </a:rPr>
+                        <a:t>Precision</a:t>
+                      </a:r>
+                    </a:p>
+                  </a:txBody>
+                  <a:tcPr>
+                    <a:solidFill>
+                      <a:schemeClr val="accent3">
+                        <a:lumMod val="40000"/>
+                        <a:lumOff val="60000"/>
+                      </a:schemeClr>
+                    </a:solidFill>
+                  </a:tcPr>
+                </a:tc>
+                <a:tc>
+                  <a:txBody>
+                    <a:bodyPr/>
+                    <a:lstStyle/>
+                    <a:p>
+                      <a:pPr>
+                        <a:lnSpc>
+                          <a:spcPct val="150000"/>
+                        </a:lnSpc>
+                      </a:pPr>
+                      <a:r>
+                        <a:rPr lang="en-ZA" sz="1200" dirty="0">
+                          <a:solidFill>
+                            <a:schemeClr val="tx2"/>
+                          </a:solidFill>
+                          <a:latin typeface="Times New Roman" panose="02020603050405020304" pitchFamily="18" charset="0"/>
+                          <a:cs typeface="Times New Roman" panose="02020603050405020304" pitchFamily="18" charset="0"/>
+                        </a:rPr>
+                        <a:t>Recall</a:t>
+                      </a:r>
+                    </a:p>
+                  </a:txBody>
+                  <a:tcPr>
+                    <a:solidFill>
+                      <a:schemeClr val="accent3">
+                        <a:lumMod val="40000"/>
+                        <a:lumOff val="60000"/>
+                      </a:schemeClr>
+                    </a:solidFill>
+                  </a:tcPr>
+                </a:tc>
+                <a:tc>
+                  <a:txBody>
+                    <a:bodyPr/>
+                    <a:lstStyle/>
+                    <a:p>
+                      <a:pPr>
+                        <a:lnSpc>
+                          <a:spcPct val="150000"/>
+                        </a:lnSpc>
+                      </a:pPr>
+                      <a:r>
+                        <a:rPr lang="en-ZA" sz="1200" dirty="0">
+                          <a:solidFill>
+                            <a:schemeClr val="tx2"/>
+                          </a:solidFill>
+                          <a:latin typeface="Times New Roman" panose="02020603050405020304" pitchFamily="18" charset="0"/>
+                          <a:cs typeface="Times New Roman" panose="02020603050405020304" pitchFamily="18" charset="0"/>
+                        </a:rPr>
+                        <a:t>F1-score</a:t>
+                      </a:r>
+                    </a:p>
+                  </a:txBody>
+                  <a:tcPr>
+                    <a:solidFill>
+                      <a:schemeClr val="accent3">
+                        <a:lumMod val="40000"/>
+                        <a:lumOff val="60000"/>
+                      </a:schemeClr>
+                    </a:solidFill>
+                  </a:tcPr>
+                </a:tc>
+                <a:extLst>
+                  <a:ext uri="{0D108BD9-81ED-4DB2-BD59-A6C34878D82A}">
+                    <a16:rowId xmlns:a16="http://schemas.microsoft.com/office/drawing/2014/main" val="3694833940"/>
+                  </a:ext>
+                </a:extLst>
+              </a:tr>
+              <a:tr h="370840">
+                <a:tc>
+                  <a:txBody>
+                    <a:bodyPr/>
+                    <a:lstStyle/>
+                    <a:p>
+                      <a:pPr>
+                        <a:lnSpc>
+                          <a:spcPct val="150000"/>
+                        </a:lnSpc>
+                      </a:pPr>
+                      <a:r>
+                        <a:rPr lang="en-ZA" sz="1200" dirty="0">
+                          <a:solidFill>
+                            <a:schemeClr val="tx2"/>
+                          </a:solidFill>
+                          <a:latin typeface="Times New Roman" panose="02020603050405020304" pitchFamily="18" charset="0"/>
+                          <a:cs typeface="Times New Roman" panose="02020603050405020304" pitchFamily="18" charset="0"/>
+                        </a:rPr>
+                        <a:t>Logistic regression</a:t>
+                      </a:r>
+                    </a:p>
+                  </a:txBody>
+                  <a:tcPr>
+                    <a:solidFill>
+                      <a:schemeClr val="accent2">
+                        <a:lumMod val="20000"/>
+                        <a:lumOff val="80000"/>
+                      </a:schemeClr>
+                    </a:solidFill>
+                  </a:tcPr>
+                </a:tc>
+                <a:tc>
+                  <a:txBody>
+                    <a:bodyPr/>
+                    <a:lstStyle/>
+                    <a:p>
+                      <a:pPr>
+                        <a:lnSpc>
+                          <a:spcPct val="150000"/>
+                        </a:lnSpc>
+                      </a:pPr>
+                      <a:r>
+                        <a:rPr lang="en-ZA" sz="1200" dirty="0">
+                          <a:solidFill>
+                            <a:schemeClr val="tx2"/>
+                          </a:solidFill>
+                          <a:latin typeface="Times New Roman" panose="02020603050405020304" pitchFamily="18" charset="0"/>
+                          <a:cs typeface="Times New Roman" panose="02020603050405020304" pitchFamily="18" charset="0"/>
+                        </a:rPr>
+                        <a:t>0.848</a:t>
+                      </a:r>
+                    </a:p>
+                  </a:txBody>
+                  <a:tcPr>
+                    <a:solidFill>
+                      <a:schemeClr val="accent2">
+                        <a:lumMod val="20000"/>
+                        <a:lumOff val="80000"/>
+                      </a:schemeClr>
+                    </a:solidFill>
+                  </a:tcPr>
+                </a:tc>
+                <a:tc>
+                  <a:txBody>
+                    <a:bodyPr/>
+                    <a:lstStyle/>
+                    <a:p>
+                      <a:pPr>
+                        <a:lnSpc>
+                          <a:spcPct val="150000"/>
+                        </a:lnSpc>
+                      </a:pPr>
+                      <a:r>
+                        <a:rPr lang="en-ZA" sz="1200" dirty="0">
+                          <a:solidFill>
+                            <a:schemeClr val="tx2"/>
+                          </a:solidFill>
+                          <a:latin typeface="Times New Roman" panose="02020603050405020304" pitchFamily="18" charset="0"/>
+                          <a:cs typeface="Times New Roman" panose="02020603050405020304" pitchFamily="18" charset="0"/>
+                        </a:rPr>
+                        <a:t>0.723</a:t>
+                      </a:r>
+                    </a:p>
+                  </a:txBody>
+                  <a:tcPr>
+                    <a:solidFill>
+                      <a:schemeClr val="accent2">
+                        <a:lumMod val="20000"/>
+                        <a:lumOff val="80000"/>
+                      </a:schemeClr>
+                    </a:solidFill>
+                  </a:tcPr>
+                </a:tc>
+                <a:tc>
+                  <a:txBody>
+                    <a:bodyPr/>
+                    <a:lstStyle/>
+                    <a:p>
+                      <a:pPr>
+                        <a:lnSpc>
+                          <a:spcPct val="150000"/>
+                        </a:lnSpc>
+                      </a:pPr>
+                      <a:r>
+                        <a:rPr lang="en-ZA" sz="1200" dirty="0">
+                          <a:solidFill>
+                            <a:schemeClr val="tx2"/>
+                          </a:solidFill>
+                          <a:latin typeface="Times New Roman" panose="02020603050405020304" pitchFamily="18" charset="0"/>
+                          <a:cs typeface="Times New Roman" panose="02020603050405020304" pitchFamily="18" charset="0"/>
+                        </a:rPr>
+                        <a:t>0.495</a:t>
+                      </a:r>
+                    </a:p>
+                  </a:txBody>
+                  <a:tcPr>
+                    <a:solidFill>
+                      <a:schemeClr val="accent2">
+                        <a:lumMod val="20000"/>
+                        <a:lumOff val="80000"/>
+                      </a:schemeClr>
+                    </a:solidFill>
+                  </a:tcPr>
+                </a:tc>
+                <a:tc>
+                  <a:txBody>
+                    <a:bodyPr/>
+                    <a:lstStyle/>
+                    <a:p>
+                      <a:pPr>
+                        <a:lnSpc>
+                          <a:spcPct val="150000"/>
+                        </a:lnSpc>
+                      </a:pPr>
+                      <a:r>
+                        <a:rPr lang="en-ZA" sz="1200" dirty="0">
+                          <a:solidFill>
+                            <a:schemeClr val="tx2"/>
+                          </a:solidFill>
+                          <a:latin typeface="Times New Roman" panose="02020603050405020304" pitchFamily="18" charset="0"/>
+                          <a:cs typeface="Times New Roman" panose="02020603050405020304" pitchFamily="18" charset="0"/>
+                        </a:rPr>
+                        <a:t>0.588</a:t>
+                      </a:r>
+                    </a:p>
+                  </a:txBody>
+                  <a:tcPr>
+                    <a:solidFill>
+                      <a:schemeClr val="accent2">
+                        <a:lumMod val="20000"/>
+                        <a:lumOff val="80000"/>
+                      </a:schemeClr>
+                    </a:solidFill>
+                  </a:tcPr>
+                </a:tc>
+                <a:extLst>
+                  <a:ext uri="{0D108BD9-81ED-4DB2-BD59-A6C34878D82A}">
+                    <a16:rowId xmlns:a16="http://schemas.microsoft.com/office/drawing/2014/main" val="2486599026"/>
+                  </a:ext>
+                </a:extLst>
+              </a:tr>
+              <a:tr h="370840">
+                <a:tc>
+                  <a:txBody>
+                    <a:bodyPr/>
+                    <a:lstStyle/>
+                    <a:p>
+                      <a:pPr>
+                        <a:lnSpc>
+                          <a:spcPct val="150000"/>
+                        </a:lnSpc>
+                      </a:pPr>
+                      <a:r>
+                        <a:rPr lang="en-ZA" sz="1200" dirty="0">
+                          <a:solidFill>
+                            <a:schemeClr val="tx2"/>
+                          </a:solidFill>
+                          <a:latin typeface="Times New Roman" panose="02020603050405020304" pitchFamily="18" charset="0"/>
+                          <a:cs typeface="Times New Roman" panose="02020603050405020304" pitchFamily="18" charset="0"/>
+                        </a:rPr>
+                        <a:t>K-NN</a:t>
+                      </a:r>
+                    </a:p>
+                  </a:txBody>
+                  <a:tcPr>
+                    <a:solidFill>
+                      <a:schemeClr val="accent2">
+                        <a:lumMod val="20000"/>
+                        <a:lumOff val="80000"/>
+                      </a:schemeClr>
+                    </a:solidFill>
+                  </a:tcPr>
+                </a:tc>
+                <a:tc>
+                  <a:txBody>
+                    <a:bodyPr/>
+                    <a:lstStyle/>
+                    <a:p>
+                      <a:pPr>
+                        <a:lnSpc>
+                          <a:spcPct val="150000"/>
+                        </a:lnSpc>
+                      </a:pPr>
+                      <a:r>
+                        <a:rPr lang="en-ZA" sz="1200" dirty="0">
+                          <a:solidFill>
+                            <a:schemeClr val="tx2"/>
+                          </a:solidFill>
+                          <a:latin typeface="Times New Roman" panose="02020603050405020304" pitchFamily="18" charset="0"/>
+                          <a:cs typeface="Times New Roman" panose="02020603050405020304" pitchFamily="18" charset="0"/>
+                        </a:rPr>
+                        <a:t>0.890</a:t>
+                      </a:r>
+                    </a:p>
+                  </a:txBody>
+                  <a:tcPr>
+                    <a:solidFill>
+                      <a:schemeClr val="accent2">
+                        <a:lumMod val="20000"/>
+                        <a:lumOff val="80000"/>
+                      </a:schemeClr>
+                    </a:solidFill>
+                  </a:tcPr>
+                </a:tc>
+                <a:tc>
+                  <a:txBody>
+                    <a:bodyPr/>
+                    <a:lstStyle/>
+                    <a:p>
+                      <a:pPr>
+                        <a:lnSpc>
+                          <a:spcPct val="150000"/>
+                        </a:lnSpc>
+                      </a:pPr>
+                      <a:r>
+                        <a:rPr lang="en-ZA" sz="1200" dirty="0">
+                          <a:solidFill>
+                            <a:schemeClr val="tx2"/>
+                          </a:solidFill>
+                          <a:latin typeface="Times New Roman" panose="02020603050405020304" pitchFamily="18" charset="0"/>
+                          <a:cs typeface="Times New Roman" panose="02020603050405020304" pitchFamily="18" charset="0"/>
+                        </a:rPr>
+                        <a:t>0.852</a:t>
+                      </a:r>
+                    </a:p>
+                  </a:txBody>
+                  <a:tcPr>
+                    <a:solidFill>
+                      <a:schemeClr val="accent2">
+                        <a:lumMod val="20000"/>
+                        <a:lumOff val="80000"/>
+                      </a:schemeClr>
+                    </a:solidFill>
+                  </a:tcPr>
+                </a:tc>
+                <a:tc>
+                  <a:txBody>
+                    <a:bodyPr/>
+                    <a:lstStyle/>
+                    <a:p>
+                      <a:pPr>
+                        <a:lnSpc>
+                          <a:spcPct val="150000"/>
+                        </a:lnSpc>
+                      </a:pPr>
+                      <a:r>
+                        <a:rPr lang="en-ZA" sz="1200" dirty="0">
+                          <a:solidFill>
+                            <a:schemeClr val="tx2"/>
+                          </a:solidFill>
+                          <a:latin typeface="Times New Roman" panose="02020603050405020304" pitchFamily="18" charset="0"/>
+                          <a:cs typeface="Times New Roman" panose="02020603050405020304" pitchFamily="18" charset="0"/>
+                        </a:rPr>
+                        <a:t>0.599</a:t>
+                      </a:r>
+                    </a:p>
+                  </a:txBody>
+                  <a:tcPr>
+                    <a:solidFill>
+                      <a:schemeClr val="accent2">
+                        <a:lumMod val="20000"/>
+                        <a:lumOff val="80000"/>
+                      </a:schemeClr>
+                    </a:solidFill>
+                  </a:tcPr>
+                </a:tc>
+                <a:tc>
+                  <a:txBody>
+                    <a:bodyPr/>
+                    <a:lstStyle/>
+                    <a:p>
+                      <a:pPr>
+                        <a:lnSpc>
+                          <a:spcPct val="150000"/>
+                        </a:lnSpc>
+                      </a:pPr>
+                      <a:r>
+                        <a:rPr lang="en-ZA" sz="1200" dirty="0">
+                          <a:solidFill>
+                            <a:schemeClr val="tx2"/>
+                          </a:solidFill>
+                          <a:latin typeface="Times New Roman" panose="02020603050405020304" pitchFamily="18" charset="0"/>
+                          <a:cs typeface="Times New Roman" panose="02020603050405020304" pitchFamily="18" charset="0"/>
+                        </a:rPr>
+                        <a:t>0.703</a:t>
+                      </a:r>
+                    </a:p>
+                  </a:txBody>
+                  <a:tcPr>
+                    <a:solidFill>
+                      <a:schemeClr val="accent2">
+                        <a:lumMod val="20000"/>
+                        <a:lumOff val="80000"/>
+                      </a:schemeClr>
+                    </a:solidFill>
+                  </a:tcPr>
+                </a:tc>
+                <a:extLst>
+                  <a:ext uri="{0D108BD9-81ED-4DB2-BD59-A6C34878D82A}">
+                    <a16:rowId xmlns:a16="http://schemas.microsoft.com/office/drawing/2014/main" val="160858611"/>
+                  </a:ext>
+                </a:extLst>
+              </a:tr>
+              <a:tr h="370840">
+                <a:tc>
+                  <a:txBody>
+                    <a:bodyPr/>
+                    <a:lstStyle/>
+                    <a:p>
+                      <a:pPr>
+                        <a:lnSpc>
+                          <a:spcPct val="150000"/>
+                        </a:lnSpc>
+                      </a:pPr>
+                      <a:r>
+                        <a:rPr lang="en-ZA" sz="1200" dirty="0">
+                          <a:solidFill>
+                            <a:schemeClr val="tx2"/>
+                          </a:solidFill>
+                          <a:latin typeface="Times New Roman" panose="02020603050405020304" pitchFamily="18" charset="0"/>
+                          <a:cs typeface="Times New Roman" panose="02020603050405020304" pitchFamily="18" charset="0"/>
+                        </a:rPr>
+                        <a:t>Decision Tree</a:t>
+                      </a:r>
+                    </a:p>
+                  </a:txBody>
+                  <a:tcPr>
+                    <a:solidFill>
+                      <a:schemeClr val="accent2">
+                        <a:lumMod val="20000"/>
+                        <a:lumOff val="80000"/>
+                      </a:schemeClr>
+                    </a:solidFill>
+                  </a:tcPr>
+                </a:tc>
+                <a:tc>
+                  <a:txBody>
+                    <a:bodyPr/>
+                    <a:lstStyle/>
+                    <a:p>
+                      <a:pPr>
+                        <a:lnSpc>
+                          <a:spcPct val="150000"/>
+                        </a:lnSpc>
+                      </a:pPr>
+                      <a:r>
+                        <a:rPr lang="en-ZA" sz="1200" dirty="0">
+                          <a:solidFill>
+                            <a:schemeClr val="tx2"/>
+                          </a:solidFill>
+                          <a:latin typeface="Times New Roman" panose="02020603050405020304" pitchFamily="18" charset="0"/>
+                          <a:cs typeface="Times New Roman" panose="02020603050405020304" pitchFamily="18" charset="0"/>
+                        </a:rPr>
+                        <a:t>0.841</a:t>
+                      </a:r>
+                    </a:p>
+                  </a:txBody>
+                  <a:tcPr>
+                    <a:solidFill>
+                      <a:schemeClr val="accent2">
+                        <a:lumMod val="20000"/>
+                        <a:lumOff val="80000"/>
+                      </a:schemeClr>
+                    </a:solidFill>
+                  </a:tcPr>
+                </a:tc>
+                <a:tc>
+                  <a:txBody>
+                    <a:bodyPr/>
+                    <a:lstStyle/>
+                    <a:p>
+                      <a:pPr>
+                        <a:lnSpc>
+                          <a:spcPct val="150000"/>
+                        </a:lnSpc>
+                      </a:pPr>
+                      <a:r>
+                        <a:rPr lang="en-ZA" sz="1200" dirty="0">
+                          <a:solidFill>
+                            <a:schemeClr val="tx2"/>
+                          </a:solidFill>
+                          <a:latin typeface="Times New Roman" panose="02020603050405020304" pitchFamily="18" charset="0"/>
+                          <a:cs typeface="Times New Roman" panose="02020603050405020304" pitchFamily="18" charset="0"/>
+                        </a:rPr>
+                        <a:t>0.631</a:t>
+                      </a:r>
+                    </a:p>
+                  </a:txBody>
+                  <a:tcPr>
+                    <a:solidFill>
+                      <a:schemeClr val="accent2">
+                        <a:lumMod val="20000"/>
+                        <a:lumOff val="80000"/>
+                      </a:schemeClr>
+                    </a:solidFill>
+                  </a:tcPr>
+                </a:tc>
+                <a:tc>
+                  <a:txBody>
+                    <a:bodyPr/>
+                    <a:lstStyle/>
+                    <a:p>
+                      <a:pPr>
+                        <a:lnSpc>
+                          <a:spcPct val="150000"/>
+                        </a:lnSpc>
+                      </a:pPr>
+                      <a:r>
+                        <a:rPr lang="en-ZA" sz="1200" dirty="0">
+                          <a:solidFill>
+                            <a:schemeClr val="tx2"/>
+                          </a:solidFill>
+                          <a:latin typeface="Times New Roman" panose="02020603050405020304" pitchFamily="18" charset="0"/>
+                          <a:cs typeface="Times New Roman" panose="02020603050405020304" pitchFamily="18" charset="0"/>
+                        </a:rPr>
+                        <a:t>0.661</a:t>
+                      </a:r>
+                    </a:p>
+                  </a:txBody>
+                  <a:tcPr>
+                    <a:solidFill>
+                      <a:schemeClr val="accent2">
+                        <a:lumMod val="20000"/>
+                        <a:lumOff val="80000"/>
+                      </a:schemeClr>
+                    </a:solidFill>
+                  </a:tcPr>
+                </a:tc>
+                <a:tc>
+                  <a:txBody>
+                    <a:bodyPr/>
+                    <a:lstStyle/>
+                    <a:p>
+                      <a:pPr>
+                        <a:lnSpc>
+                          <a:spcPct val="150000"/>
+                        </a:lnSpc>
+                      </a:pPr>
+                      <a:r>
+                        <a:rPr lang="en-ZA" sz="1200" dirty="0">
+                          <a:solidFill>
+                            <a:schemeClr val="tx2"/>
+                          </a:solidFill>
+                          <a:latin typeface="Times New Roman" panose="02020603050405020304" pitchFamily="18" charset="0"/>
+                          <a:cs typeface="Times New Roman" panose="02020603050405020304" pitchFamily="18" charset="0"/>
+                        </a:rPr>
+                        <a:t>0.646</a:t>
+                      </a:r>
+                    </a:p>
+                  </a:txBody>
+                  <a:tcPr>
+                    <a:solidFill>
+                      <a:schemeClr val="accent2">
+                        <a:lumMod val="20000"/>
+                        <a:lumOff val="80000"/>
+                      </a:schemeClr>
+                    </a:solidFill>
+                  </a:tcPr>
+                </a:tc>
+                <a:extLst>
+                  <a:ext uri="{0D108BD9-81ED-4DB2-BD59-A6C34878D82A}">
+                    <a16:rowId xmlns:a16="http://schemas.microsoft.com/office/drawing/2014/main" val="1992246048"/>
+                  </a:ext>
+                </a:extLst>
+              </a:tr>
+            </a:tbl>
+          </a:graphicData>
+        </a:graphic>
+      </p:graphicFrame>
+      <p:pic>
+        <p:nvPicPr>
+          <p:cNvPr id="10" name="Picture 9">
+            <a:extLst>
+              <a:ext uri="{FF2B5EF4-FFF2-40B4-BE49-F238E27FC236}">
+                <a16:creationId xmlns:a16="http://schemas.microsoft.com/office/drawing/2014/main" id="{DDB6FD70-7166-B5A2-F84E-BE650511D505}"/>
+              </a:ext>
+            </a:extLst>
+          </p:cNvPr>
+          <p:cNvPicPr>
+            <a:picLocks noChangeAspect="1"/>
+          </p:cNvPicPr>
+          <p:nvPr/>
+        </p:nvPicPr>
+        <p:blipFill>
+          <a:blip r:embed="rId2"/>
+          <a:stretch>
+            <a:fillRect/>
+          </a:stretch>
+        </p:blipFill>
+        <p:spPr>
+          <a:xfrm>
+            <a:off x="681135" y="3452525"/>
+            <a:ext cx="6214187" cy="3197143"/>
+          </a:xfrm>
+          <a:prstGeom prst="rect">
+            <a:avLst/>
+          </a:prstGeom>
+        </p:spPr>
+      </p:pic>
+      <p:sp>
+        <p:nvSpPr>
+          <p:cNvPr id="12" name="TextBox 11">
+            <a:extLst>
+              <a:ext uri="{FF2B5EF4-FFF2-40B4-BE49-F238E27FC236}">
+                <a16:creationId xmlns:a16="http://schemas.microsoft.com/office/drawing/2014/main" id="{C4CDB01D-D9F1-2BB5-1F85-04A8D58029B2}"/>
+              </a:ext>
+            </a:extLst>
+          </p:cNvPr>
+          <p:cNvSpPr txBox="1"/>
+          <p:nvPr/>
+        </p:nvSpPr>
+        <p:spPr>
+          <a:xfrm>
+            <a:off x="7651100" y="3750905"/>
+            <a:ext cx="3666931" cy="1167114"/>
+          </a:xfrm>
+          <a:prstGeom prst="rect">
+            <a:avLst/>
+          </a:prstGeom>
+          <a:noFill/>
+        </p:spPr>
+        <p:txBody>
+          <a:bodyPr wrap="square" rtlCol="0">
+            <a:spAutoFit/>
+          </a:bodyPr>
+          <a:lstStyle/>
+          <a:p>
+            <a:pPr>
+              <a:lnSpc>
+                <a:spcPct val="150000"/>
+              </a:lnSpc>
+            </a:pPr>
+            <a:r>
+              <a:rPr lang="en-ZA" sz="1200" dirty="0">
+                <a:solidFill>
+                  <a:schemeClr val="tx2"/>
+                </a:solidFill>
+                <a:latin typeface="Times New Roman" panose="02020603050405020304" pitchFamily="18" charset="0"/>
+                <a:cs typeface="Times New Roman" panose="02020603050405020304" pitchFamily="18" charset="0"/>
+              </a:rPr>
+              <a:t>PCA gave almost the same results for </a:t>
+            </a:r>
+            <a:r>
+              <a:rPr lang="en-ZA" sz="1200" b="1" dirty="0">
+                <a:solidFill>
+                  <a:schemeClr val="tx2"/>
+                </a:solidFill>
+                <a:latin typeface="Times New Roman" panose="02020603050405020304" pitchFamily="18" charset="0"/>
+                <a:cs typeface="Times New Roman" panose="02020603050405020304" pitchFamily="18" charset="0"/>
+              </a:rPr>
+              <a:t>Logistic Regression </a:t>
+            </a:r>
+            <a:r>
+              <a:rPr lang="en-ZA" sz="1200" dirty="0">
+                <a:solidFill>
+                  <a:schemeClr val="tx2"/>
+                </a:solidFill>
+                <a:latin typeface="Times New Roman" panose="02020603050405020304" pitchFamily="18" charset="0"/>
+                <a:cs typeface="Times New Roman" panose="02020603050405020304" pitchFamily="18" charset="0"/>
+              </a:rPr>
+              <a:t>and </a:t>
+            </a:r>
+            <a:r>
+              <a:rPr lang="en-ZA" sz="1200" b="1" dirty="0">
+                <a:solidFill>
+                  <a:schemeClr val="tx2"/>
+                </a:solidFill>
+                <a:latin typeface="Times New Roman" panose="02020603050405020304" pitchFamily="18" charset="0"/>
+                <a:cs typeface="Times New Roman" panose="02020603050405020304" pitchFamily="18" charset="0"/>
+              </a:rPr>
+              <a:t>KNN </a:t>
+            </a:r>
+            <a:r>
+              <a:rPr lang="en-ZA" sz="1200" dirty="0">
+                <a:solidFill>
+                  <a:schemeClr val="tx2"/>
+                </a:solidFill>
+                <a:latin typeface="Times New Roman" panose="02020603050405020304" pitchFamily="18" charset="0"/>
+                <a:cs typeface="Times New Roman" panose="02020603050405020304" pitchFamily="18" charset="0"/>
+              </a:rPr>
+              <a:t>but hurt the Decision tree which loses meaning once features are rotated into components.</a:t>
+            </a:r>
+          </a:p>
+        </p:txBody>
+      </p:sp>
+    </p:spTree>
+    <p:extLst>
+      <p:ext uri="{BB962C8B-B14F-4D97-AF65-F5344CB8AC3E}">
+        <p14:creationId xmlns:p14="http://schemas.microsoft.com/office/powerpoint/2010/main" val="2713236424"/>
+      </p:ext>
+    </p:extLst>
+  </p:cSld>
+  <p:clrMapOvr>
+    <a:masterClrMapping/>
+  </p:clrMapOvr>
+</p:sld>
+</file>
+
+<file path=ppt/slides/slide9.xml><?xml version="1.0" encoding="utf-8"?>
+<p:sld xmlns:a="http://schemas.openxmlformats.org/drawingml/2006/main" xmlns:r="http://schemas.openxmlformats.org/officeDocument/2006/relationships" xmlns:p="http://schemas.openxmlformats.org/presentationml/2006/main">
+  <p:cSld>
+    <p:spTree>
+      <p:nvGrpSpPr>
+        <p:cNvPr id="1" name=""/>
+        <p:cNvGrpSpPr/>
+        <p:nvPr/>
+      </p:nvGrpSpPr>
+      <p:grpSpPr>
+        <a:xfrm>
+          <a:off x="0" y="0"/>
+          <a:ext cx="0" cy="0"/>
+          <a:chOff x="0" y="0"/>
+          <a:chExt cx="0" cy="0"/>
+        </a:xfrm>
+      </p:grpSpPr>
+      <p:sp>
+        <p:nvSpPr>
+          <p:cNvPr id="2" name="Slide Number Placeholder 1">
+            <a:extLst>
+              <a:ext uri="{FF2B5EF4-FFF2-40B4-BE49-F238E27FC236}">
+                <a16:creationId xmlns:a16="http://schemas.microsoft.com/office/drawing/2014/main" id="{7A9FAB60-913D-6D7F-D5A1-DB15232395A1}"/>
+              </a:ext>
+            </a:extLst>
+          </p:cNvPr>
+          <p:cNvSpPr>
+            <a:spLocks noGrp="1"/>
+          </p:cNvSpPr>
+          <p:nvPr>
+            <p:ph type="sldNum" sz="quarter" idx="12"/>
+          </p:nvPr>
+        </p:nvSpPr>
+        <p:spPr/>
+        <p:txBody>
+          <a:bodyPr/>
+          <a:lstStyle/>
+          <a:p>
+            <a:fld id="{AEAA3239-9EA4-4A65-A281-97F994456D9F}" type="slidenum">
+              <a:rPr lang="en-US" smtClean="0"/>
+              <a:t>9</a:t>
+            </a:fld>
+            <a:endParaRPr lang="en-US"/>
+          </a:p>
+        </p:txBody>
+      </p:sp>
+      <p:sp>
+        <p:nvSpPr>
+          <p:cNvPr id="3" name="TextBox 2">
+            <a:extLst>
+              <a:ext uri="{FF2B5EF4-FFF2-40B4-BE49-F238E27FC236}">
+                <a16:creationId xmlns:a16="http://schemas.microsoft.com/office/drawing/2014/main" id="{C22A7DEA-FEE9-B9CB-5AF6-E2858E6D632E}"/>
+              </a:ext>
+            </a:extLst>
+          </p:cNvPr>
+          <p:cNvSpPr txBox="1"/>
+          <p:nvPr/>
+        </p:nvSpPr>
+        <p:spPr>
+          <a:xfrm>
+            <a:off x="606490" y="382555"/>
+            <a:ext cx="3858685" cy="661207"/>
+          </a:xfrm>
+          <a:prstGeom prst="rect">
+            <a:avLst/>
+          </a:prstGeom>
+          <a:noFill/>
+        </p:spPr>
+        <p:txBody>
+          <a:bodyPr wrap="none" rtlCol="0">
+            <a:spAutoFit/>
+          </a:bodyPr>
+          <a:lstStyle/>
+          <a:p>
+            <a:pPr>
+              <a:lnSpc>
+                <a:spcPct val="150000"/>
+              </a:lnSpc>
+            </a:pPr>
+            <a:r>
+              <a:rPr lang="en-ZA" sz="2800" b="1" dirty="0">
+                <a:solidFill>
+                  <a:schemeClr val="tx2"/>
+                </a:solidFill>
+                <a:latin typeface="Times New Roman" panose="02020603050405020304" pitchFamily="18" charset="0"/>
+                <a:cs typeface="Times New Roman" panose="02020603050405020304" pitchFamily="18" charset="0"/>
+              </a:rPr>
+              <a:t>Hyperparameter tuning</a:t>
+            </a:r>
+          </a:p>
+        </p:txBody>
+      </p:sp>
+    </p:spTree>
+    <p:extLst>
+      <p:ext uri="{BB962C8B-B14F-4D97-AF65-F5344CB8AC3E}">
+        <p14:creationId xmlns:p14="http://schemas.microsoft.com/office/powerpoint/2010/main" val="4292511079"/>
       </p:ext>
     </p:extLst>
   </p:cSld>

</xml_diff>